<commit_message>
Hero banner and deck: real numbers from today's live run
Co-Authored-By: Claude Opus 5.5 <noreply@anthropic.com>
</commit_message>
<xml_diff>
--- a/deck/ColdOpen.pptx
+++ b/deck/ColdOpen.pptx
@@ -8506,7 +8506,7 @@
                 <a:ea typeface="Arial"/>
                 <a:cs typeface="Arial"/>
               </a:rPr>
-              <a:t>Live Mission Control · 2:27 PM PT · Sep 28, 2026</a:t>
+              <a:t>Live Mission Control · 2:30 PM PT · Sep 28, 2026</a:t>
             </a:r>
           </a:p>
         </p:txBody>
@@ -14532,7 +14532,7 @@
                 <a:ea typeface="Arial"/>
                 <a:cs typeface="Arial"/>
               </a:rPr>
-              <a:t>LIVE FROM /API/STATE · 2:27 PM PT · SEP 28, 2026</a:t>
+              <a:t>LIVE FROM /API/STATE · 2:30 PM PT · SEP 28, 2026</a:t>
             </a:r>
           </a:p>
         </p:txBody>

</xml_diff>